<commit_message>
docs(conference): P12 numbers, poster, slides, Q&A, one-pager and paper updated with coordination results (P12 12.14)
</commit_message>
<xml_diff>
--- a/conference/poster/poster_draft.pptx
+++ b/conference/poster/poster_draft.pptx
@@ -3597,14 +3597,14 @@
               <a:defRPr sz="2800" b="0"/>
             </a:pPr>
             <a:r>
-              <a:t>Ten simulated generations: the recommender cut realised inbreeding by 1.5 points in the small breed and nearly removed affected puppies at tested loci. Long-term diversity needs coordinated sire use: random mating kept Ne at 87 versus 32.</a:t>
+              <a:t>Ten simulated generations: the recommender cut realised inbreeding by 1.5 points in the small breed and nearly removed affected puppies at tested loci, but breeders all chose the same sires. Club quotas fix this: coordinated sire planning raised Ne from 33 (today's market) to 54 in the small breed and from 188 to 283 in the medium breed; the recommender within quotas did as well. Random mating still kept the most diversity in the medium breed.</a:t>
             </a:r>
           </a:p>
         </p:txBody>
       </p:sp>
       <p:pic>
         <p:nvPicPr>
-          <p:cNvPr id="17" name="Picture 16" descr="figA_realised_inbreeding_poster.png"/>
+          <p:cNvPr id="17" name="Picture 16" descr="figG_coordination_poster.png"/>
           <p:cNvPicPr>
             <a:picLocks noChangeAspect="1"/>
           </p:cNvPicPr>
@@ -3619,7 +3619,7 @@
         <p:spPr>
           <a:xfrm>
             <a:off x="1080000" y="29502065"/>
-            <a:ext cx="14760000" cy="6279026"/>
+            <a:ext cx="14760000" cy="5477093"/>
           </a:xfrm>
           <a:prstGeom prst="rect">
             <a:avLst/>
@@ -3693,7 +3693,7 @@
         </p:nvSpPr>
         <p:spPr>
           <a:xfrm>
-            <a:off x="1080000" y="36141092"/>
+            <a:off x="1080000" y="35339159"/>
             <a:ext cx="14760000" cy="720000"/>
           </a:xfrm>
           <a:prstGeom prst="rect">
@@ -3728,7 +3728,7 @@
         </p:nvSpPr>
         <p:spPr>
           <a:xfrm>
-            <a:off x="1080000" y="36969092"/>
+            <a:off x="1080000" y="36167159"/>
             <a:ext cx="14760000" cy="2160000"/>
           </a:xfrm>
           <a:prstGeom prst="rect">
@@ -3759,7 +3759,7 @@
         </p:nvSpPr>
         <p:spPr>
           <a:xfrm>
-            <a:off x="16560000" y="36141092"/>
+            <a:off x="16560000" y="35339159"/>
             <a:ext cx="14760000" cy="720000"/>
           </a:xfrm>
           <a:prstGeom prst="rect">
@@ -3794,7 +3794,7 @@
         </p:nvSpPr>
         <p:spPr>
           <a:xfrm>
-            <a:off x="16560000" y="36969092"/>
+            <a:off x="16560000" y="36167159"/>
             <a:ext cx="14760000" cy="2160000"/>
           </a:xfrm>
           <a:prstGeom prst="rect">

</xml_diff>

<commit_message>
feat(conference): product-first poster text with E9 results and policy-dial figure
Poster sections: three tools for three roles at a kennel club, recorded vs true COI, E9
(replicated) result with figure N, honesty box. E9 numbers generated from the reports
(build_numbers.e9). Figure N poster variant: one large SYN_M panel and readable labels.
</commit_message>
<xml_diff>
--- a/conference/poster/poster_draft.pptx
+++ b/conference/poster/poster_draft.pptx
@@ -3327,7 +3327,7 @@
         <p:spPr>
           <a:xfrm>
             <a:off x="1080000" y="9468000"/>
-            <a:ext cx="30240000" cy="792000"/>
+            <a:ext cx="30240000" cy="1152000"/>
           </a:xfrm>
           <a:prstGeom prst="rect">
             <a:avLst/>
@@ -3344,7 +3344,7 @@
               <a:defRPr sz="3000" b="0"/>
             </a:pPr>
             <a:r>
-              <a:t>EU Regulation 2026/1818 bans close-relative matings across the EU.</a:t>
+              <a:t>EU Regulation 2026/1818 bans close-relative matings. Clubs must check every mating, but today they have lookup tools, not decision tools.</a:t>
             </a:r>
           </a:p>
         </p:txBody>
@@ -3357,7 +3357,7 @@
         </p:nvSpPr>
         <p:spPr>
           <a:xfrm>
-            <a:off x="1080000" y="10260000"/>
+            <a:off x="1080000" y="10620000"/>
             <a:ext cx="30240000" cy="720000"/>
           </a:xfrm>
           <a:prstGeom prst="rect">
@@ -3379,7 +3379,7 @@
               </a:defRPr>
             </a:pPr>
             <a:r>
-              <a:t>What we built</a:t>
+              <a:t>One engine, three tools for a kennel club</a:t>
             </a:r>
           </a:p>
         </p:txBody>
@@ -3392,8 +3392,8 @@
         </p:nvSpPr>
         <p:spPr>
           <a:xfrm>
-            <a:off x="1080000" y="11088000"/>
-            <a:ext cx="30240000" cy="1872000"/>
+            <a:off x="1080000" y="11448000"/>
+            <a:ext cx="30240000" cy="3131999"/>
           </a:xfrm>
           <a:prstGeom prst="rect">
             <a:avLst/>
@@ -3410,7 +3410,23 @@
               <a:defRPr sz="3000" b="0"/>
             </a:pPr>
             <a:r>
-              <a:t>An open engine: exact inbreeding and kinship, EU, FCI and kennel-club rules, and an explained score for every candidate sire. Tested on a calibrated synthetic registry (153,641 dogs; 39 of 47 calibration checks pass, 8 soft warnings, 0 failures).</a:t>
+              <a:t>• **Breeders: Mate finder.** Every candidate sire ranked and explained: inbreeding, breed diversity, DNA risk, hips, sire use, rules.</a:t>
+            </a:r>
+          </a:p>
+          <a:p>
+            <a:pPr>
+              <a:defRPr sz="3000" b="0"/>
+            </a:pPr>
+            <a:r>
+              <a:t>• **Breeding officer: Kennel club desk.** Mating applications checked against EU, FCI and club rules before the mating.</a:t>
+            </a:r>
+          </a:p>
+          <a:p>
+            <a:pPr>
+              <a:defRPr sz="3000" b="0"/>
+            </a:pPr>
+            <a:r>
+              <a:t>• **Breeding committee: Club planner.** Yearly litter quotas per sire: the club sets an inbreeding budget and sees what it buys.</a:t>
             </a:r>
           </a:p>
         </p:txBody>
@@ -3423,7 +3439,7 @@
         </p:nvSpPr>
         <p:spPr>
           <a:xfrm>
-            <a:off x="1080000" y="12960000"/>
+            <a:off x="1080000" y="14580000"/>
             <a:ext cx="30240000" cy="900000"/>
           </a:xfrm>
           <a:prstGeom prst="rect">
@@ -3454,7 +3470,7 @@
         </p:nvSpPr>
         <p:spPr>
           <a:xfrm>
-            <a:off x="1080000" y="14040000"/>
+            <a:off x="1080000" y="15660000"/>
             <a:ext cx="30240000" cy="720000"/>
           </a:xfrm>
           <a:prstGeom prst="rect">
@@ -3489,7 +3505,7 @@
         </p:nvSpPr>
         <p:spPr>
           <a:xfrm>
-            <a:off x="1080000" y="14867999"/>
+            <a:off x="1080000" y="16487999"/>
             <a:ext cx="30240000" cy="900000"/>
           </a:xfrm>
           <a:prstGeom prst="rect">
@@ -3507,7 +3523,7 @@
               <a:defRPr sz="3000" b="0"/>
             </a:pPr>
             <a:r>
-              <a:t>2025 puppies of the small breed: recorded COI 10.9%, true inbreeding 43.7%.</a:t>
+              <a:t>Small breed, 2025 puppies: recorded COI 10.9%, true inbreeding 43.7%.</a:t>
             </a:r>
           </a:p>
         </p:txBody>
@@ -3528,7 +3544,7 @@
         </p:blipFill>
         <p:spPr>
           <a:xfrm>
-            <a:off x="1080000" y="15840000"/>
+            <a:off x="1080000" y="17460000"/>
             <a:ext cx="30240000" cy="9162066"/>
           </a:xfrm>
           <a:prstGeom prst="rect">
@@ -3544,7 +3560,7 @@
         </p:nvSpPr>
         <p:spPr>
           <a:xfrm>
-            <a:off x="1080000" y="25362065"/>
+            <a:off x="1080000" y="26982065"/>
             <a:ext cx="14760000" cy="720000"/>
           </a:xfrm>
           <a:prstGeom prst="rect">
@@ -3579,7 +3595,7 @@
         </p:nvSpPr>
         <p:spPr>
           <a:xfrm>
-            <a:off x="1080000" y="26190065"/>
+            <a:off x="1080000" y="27810065"/>
             <a:ext cx="14760000" cy="3240000"/>
           </a:xfrm>
           <a:prstGeom prst="rect">
@@ -3597,14 +3613,14 @@
               <a:defRPr sz="2800" b="0"/>
             </a:pPr>
             <a:r>
-              <a:t>Ten simulated generations: the recommender cut realised inbreeding by 1.5 points in the small breed and nearly removed affected puppies at tested loci, but breeders all chose the same sires. Club quotas fix this: coordinated sire planning raised Ne from 33 (today's market) to 54 in the small breed and from 188 to 283 in the medium breed; the recommender within quotas did as well. Random mating still kept the most diversity in the medium breed.</a:t>
+              <a:t>Ten simulated generations on a calibrated synthetic registry (153,641 dogs), with criteria fixed before every run. Club quotas with a hips budget (inbreeding rise at most 0.1% per generation) and a carrier limit beat today's market on all three at once in the medium breed: Ne +85 (+48 to +122), hip breeding value -1.17, disease-allele frequency 79% lower. Replicated on an independent seed. At the lowest budget, diversity stayed at the level of plain quotas while hips and disease alleles still improved.</a:t>
             </a:r>
           </a:p>
         </p:txBody>
       </p:sp>
       <p:pic>
         <p:nvPicPr>
-          <p:cNvPr id="17" name="Picture 16" descr="figG_coordination_poster.png"/>
+          <p:cNvPr id="17" name="Picture 16" descr="figN_policy_dial_poster.png"/>
           <p:cNvPicPr>
             <a:picLocks noChangeAspect="1"/>
           </p:cNvPicPr>
@@ -3618,8 +3634,8 @@
         </p:blipFill>
         <p:spPr>
           <a:xfrm>
-            <a:off x="1080000" y="29502065"/>
-            <a:ext cx="14760000" cy="5477093"/>
+            <a:off x="1080000" y="31122065"/>
+            <a:ext cx="14760000" cy="6450978"/>
           </a:xfrm>
           <a:prstGeom prst="rect">
             <a:avLst/>
@@ -3634,7 +3650,7 @@
         </p:nvSpPr>
         <p:spPr>
           <a:xfrm>
-            <a:off x="16560000" y="25362065"/>
+            <a:off x="16560000" y="26982065"/>
             <a:ext cx="14760000" cy="720000"/>
           </a:xfrm>
           <a:prstGeom prst="rect">
@@ -3677,7 +3693,7 @@
         </p:blipFill>
         <p:spPr>
           <a:xfrm>
-            <a:off x="16560000" y="26262065"/>
+            <a:off x="16560000" y="27882065"/>
             <a:ext cx="14760000" cy="7674180"/>
           </a:xfrm>
           <a:prstGeom prst="rect">
@@ -3693,7 +3709,7 @@
         </p:nvSpPr>
         <p:spPr>
           <a:xfrm>
-            <a:off x="1080000" y="35339159"/>
+            <a:off x="1080000" y="37933044"/>
             <a:ext cx="14760000" cy="720000"/>
           </a:xfrm>
           <a:prstGeom prst="rect">
@@ -3728,7 +3744,7 @@
         </p:nvSpPr>
         <p:spPr>
           <a:xfrm>
-            <a:off x="1080000" y="36167159"/>
+            <a:off x="1080000" y="38761043"/>
             <a:ext cx="14760000" cy="2160000"/>
           </a:xfrm>
           <a:prstGeom prst="rect">
@@ -3746,7 +3762,7 @@
               <a:defRPr sz="2800" b="0"/>
             </a:pPr>
             <a:r>
-              <a:t>All dogs are synthetic. Results are in silico. Some EU rules are not yet verified.</a:t>
+              <a:t>All dogs are synthetic; results are in silico. The carrier limit works when most breeders take part. Some EU rules are not yet verified.</a:t>
             </a:r>
           </a:p>
         </p:txBody>
@@ -3759,7 +3775,7 @@
         </p:nvSpPr>
         <p:spPr>
           <a:xfrm>
-            <a:off x="16560000" y="35339159"/>
+            <a:off x="16560000" y="37933044"/>
             <a:ext cx="14760000" cy="720000"/>
           </a:xfrm>
           <a:prstGeom prst="rect">
@@ -3794,7 +3810,7 @@
         </p:nvSpPr>
         <p:spPr>
           <a:xfrm>
-            <a:off x="16560000" y="36167159"/>
+            <a:off x="16560000" y="38761043"/>
             <a:ext cx="14760000" cy="2160000"/>
           </a:xfrm>
           <a:prstGeom prst="rect">
@@ -3812,7 +3828,7 @@
               <a:defRPr sz="2800" b="0"/>
             </a:pPr>
             <a:r>
-              <a:t>Free pilot for kennel and breed clubs; code runs on your premises.</a:t>
+              <a:t>Free pilot for kennel and breed clubs: one breed, your data stays on your servers. Scan for the live demo and code.</a:t>
             </a:r>
           </a:p>
           <a:p>
@@ -3851,7 +3867,7 @@
               <a:defRPr sz="2000" b="0"/>
             </a:pPr>
             <a:r>
-              <a:t>Refs: Bannasch 2021; Lewis 2015; Donner 2023; Meuwissen and Luo 1992; Colleau 2002.</a:t>
+              <a:t>Refs: Bannasch 2021; Lewis 2015; Donner 2023; Meuwissen and Luo 1992; Meuwissen 1997.</a:t>
             </a:r>
           </a:p>
         </p:txBody>

</xml_diff>